<commit_message>
Fix session delete routing and pitch materials
</commit_message>
<xml_diff>
--- a/docs/Cadence_Pitch.pptx
+++ b/docs/Cadence_Pitch.pptx
@@ -2,17 +2,17 @@
 <file path=ppt/presentation.xml><?xml version="1.0" encoding="utf-8"?>
 <p:presentation xmlns:p="http://schemas.openxmlformats.org/presentationml/2006/main">
   <p:sldMasterIdLst>
-    <p:sldMasterId xmlns:r="http://schemas.openxmlformats.org/officeDocument/2006/relationships" id="2147483648" r:id="R6c2be2b71b7b4699"/>
+    <p:sldMasterId xmlns:r="http://schemas.openxmlformats.org/officeDocument/2006/relationships" id="2147483648" r:id="R987b51621edb49c7"/>
   </p:sldMasterIdLst>
   <p:notesMasterIdLst>
-    <p:notesMasterId xmlns:r="http://schemas.openxmlformats.org/officeDocument/2006/relationships" r:id="R77475e1510ba4f3e"/>
+    <p:notesMasterId xmlns:r="http://schemas.openxmlformats.org/officeDocument/2006/relationships" r:id="R75e172e6bf4c49e1"/>
   </p:notesMasterIdLst>
   <p:sldIdLst>
-    <p:sldId xmlns:r="http://schemas.openxmlformats.org/officeDocument/2006/relationships" id="256" r:id="Rd048a95933704b66"/>
-    <p:sldId xmlns:r="http://schemas.openxmlformats.org/officeDocument/2006/relationships" id="257" r:id="Reae9bbf1042c4a2b"/>
-    <p:sldId xmlns:r="http://schemas.openxmlformats.org/officeDocument/2006/relationships" id="258" r:id="R386d1526f9284fc9"/>
-    <p:sldId xmlns:r="http://schemas.openxmlformats.org/officeDocument/2006/relationships" id="259" r:id="R6eb97fe86c7c4dcc"/>
-    <p:sldId xmlns:r="http://schemas.openxmlformats.org/officeDocument/2006/relationships" id="260" r:id="R2ae94f8c3fe54081"/>
+    <p:sldId xmlns:r="http://schemas.openxmlformats.org/officeDocument/2006/relationships" id="256" r:id="Ra9037aeab69549c2"/>
+    <p:sldId xmlns:r="http://schemas.openxmlformats.org/officeDocument/2006/relationships" id="257" r:id="R81a74dfd863648d2"/>
+    <p:sldId xmlns:r="http://schemas.openxmlformats.org/officeDocument/2006/relationships" id="258" r:id="R75b31f2cbada4f09"/>
+    <p:sldId xmlns:r="http://schemas.openxmlformats.org/officeDocument/2006/relationships" id="259" r:id="Rea47563fdba64913"/>
+    <p:sldId xmlns:r="http://schemas.openxmlformats.org/officeDocument/2006/relationships" id="260" r:id="R973ee344774b4233"/>
   </p:sldIdLst>
   <p:sldSz cx="12192000" cy="6858000"/>
   <p:notesSz cx="6858000" cy="9144000"/>
@@ -794,7 +794,7 @@
   </p:cSld>
   <p:clrMap bg1="lt1" tx1="dk1" bg2="lt2" tx2="dk2" accent1="accent1" accent2="accent2" accent3="accent3" accent4="accent4" accent5="accent5" accent6="accent6" hlink="hlink" folHlink="folHlink"/>
   <p:sldLayoutIdLst>
-    <p:sldLayoutId xmlns:r="http://schemas.openxmlformats.org/officeDocument/2006/relationships" id="2147483649" r:id="Rfb1ca92f29c44281"/>
+    <p:sldLayoutId xmlns:r="http://schemas.openxmlformats.org/officeDocument/2006/relationships" id="2147483649" r:id="R888244decfdd4265"/>
   </p:sldLayoutIdLst>
   <p:txStyles>
     <p:titleStyle>
@@ -1342,14 +1342,14 @@
       </p:grpSpPr>
       <p:pic>
         <p:nvPicPr>
-          <p:cNvPr id="6" name=""/>
+          <p:cNvPr id="7" name=""/>
           <p:cNvPicPr>
             <a:picLocks xmlns:a="http://schemas.openxmlformats.org/drawingml/2006/main" noChangeAspect="1"/>
           </p:cNvPicPr>
           <p:nvPr/>
         </p:nvPicPr>
         <p:blipFill>
-          <a:blip xmlns:r="http://schemas.openxmlformats.org/officeDocument/2006/relationships" xmlns:a="http://schemas.openxmlformats.org/drawingml/2006/main" r:embed="R2e4babaebfe04453"/>
+          <a:blip xmlns:r="http://schemas.openxmlformats.org/officeDocument/2006/relationships" xmlns:a="http://schemas.openxmlformats.org/drawingml/2006/main" r:embed="Rb235ead78ea947ea"/>
           <a:srcRect xmlns:a="http://schemas.openxmlformats.org/drawingml/2006/main" l="26163" t="0" r="26163" b="0"/>
           <a:stretch xmlns:a="http://schemas.openxmlformats.org/drawingml/2006/main">
             <a:fillRect l="0" t="0" r="0" b="0"/>
@@ -1399,6 +1399,7 @@
           <a:lstStyle xmlns:a="http://schemas.openxmlformats.org/drawingml/2006/main"/>
           <a:p xmlns:a="http://schemas.openxmlformats.org/drawingml/2006/main">
             <a:pPr algn="l">
+              <a:buNone/>
               <a:defRPr sz="1575" b="1">
                 <a:solidFill>
                   <a:srgbClr val="E98232"/>
@@ -1456,6 +1457,7 @@
           <a:lstStyle xmlns:a="http://schemas.openxmlformats.org/drawingml/2006/main"/>
           <a:p xmlns:a="http://schemas.openxmlformats.org/drawingml/2006/main">
             <a:pPr algn="l">
+              <a:buNone/>
               <a:defRPr sz="4575" b="1">
                 <a:solidFill>
                   <a:srgbClr val="FFFFFF"/>
@@ -1479,6 +1481,7 @@
           </a:p>
           <a:p xmlns:a="http://schemas.openxmlformats.org/drawingml/2006/main">
             <a:pPr algn="l">
+              <a:buNone/>
               <a:defRPr sz="4575" b="1">
                 <a:solidFill>
                   <a:srgbClr val="FFFFFF"/>
@@ -1536,6 +1539,7 @@
           <a:lstStyle xmlns:a="http://schemas.openxmlformats.org/drawingml/2006/main"/>
           <a:p xmlns:a="http://schemas.openxmlformats.org/drawingml/2006/main">
             <a:pPr algn="l">
+              <a:buNone/>
               <a:defRPr sz="2025" b="0">
                 <a:solidFill>
                   <a:srgbClr val="E2E4E7"/>
@@ -1593,6 +1597,7 @@
           <a:lstStyle xmlns:a="http://schemas.openxmlformats.org/drawingml/2006/main"/>
           <a:p xmlns:a="http://schemas.openxmlformats.org/drawingml/2006/main">
             <a:pPr algn="l">
+              <a:buNone/>
               <a:defRPr sz="1350" b="0">
                 <a:solidFill>
                   <a:srgbClr val="C5C8CC"/>
@@ -1611,7 +1616,7 @@
                 <a:ea typeface="Arial"/>
                 <a:cs typeface="Arial"/>
               </a:rPr>
-              <a:t>Five-minute project pitch  |  October 8, 2026</a:t>
+              <a:t>Live URL: https://cadenceproject.vercel.app</a:t>
             </a:r>
           </a:p>
         </p:txBody>
@@ -1679,6 +1684,7 @@
           <a:lstStyle xmlns:a="http://schemas.openxmlformats.org/drawingml/2006/main"/>
           <a:p xmlns:a="http://schemas.openxmlformats.org/drawingml/2006/main">
             <a:pPr algn="l">
+              <a:buNone/>
               <a:defRPr sz="3600" b="1">
                 <a:solidFill>
                   <a:srgbClr val="111317"/>
@@ -1702,6 +1708,7 @@
           </a:p>
           <a:p xmlns:a="http://schemas.openxmlformats.org/drawingml/2006/main">
             <a:pPr algn="l">
+              <a:buNone/>
               <a:defRPr sz="3600" b="1">
                 <a:solidFill>
                   <a:srgbClr val="111317"/>
@@ -1759,6 +1766,7 @@
           <a:lstStyle xmlns:a="http://schemas.openxmlformats.org/drawingml/2006/main"/>
           <a:p xmlns:a="http://schemas.openxmlformats.org/drawingml/2006/main">
             <a:pPr algn="l">
+              <a:buNone/>
               <a:defRPr sz="2025" b="0">
                 <a:solidFill>
                   <a:srgbClr val="29313A"/>
@@ -1816,6 +1824,7 @@
           <a:lstStyle xmlns:a="http://schemas.openxmlformats.org/drawingml/2006/main"/>
           <a:p xmlns:a="http://schemas.openxmlformats.org/drawingml/2006/main">
             <a:pPr algn="l">
+              <a:buNone/>
               <a:defRPr sz="1800" b="0">
                 <a:solidFill>
                   <a:srgbClr val="6A737C"/>
@@ -1841,14 +1850,14 @@
       </p:sp>
       <p:pic>
         <p:nvPicPr>
-          <p:cNvPr id="9" name=""/>
+          <p:cNvPr id="11" name=""/>
           <p:cNvPicPr>
             <a:picLocks xmlns:a="http://schemas.openxmlformats.org/drawingml/2006/main" noChangeAspect="1"/>
           </p:cNvPicPr>
           <p:nvPr/>
         </p:nvPicPr>
         <p:blipFill>
-          <a:blip xmlns:r="http://schemas.openxmlformats.org/officeDocument/2006/relationships" xmlns:a="http://schemas.openxmlformats.org/drawingml/2006/main" r:embed="R6f8e6b36cb364548"/>
+          <a:blip xmlns:r="http://schemas.openxmlformats.org/officeDocument/2006/relationships" xmlns:a="http://schemas.openxmlformats.org/drawingml/2006/main" r:embed="Rc90b48adc7f44a33"/>
           <a:srcRect xmlns:a="http://schemas.openxmlformats.org/drawingml/2006/main" l="8140" t="0" r="8140" b="0"/>
           <a:stretch xmlns:a="http://schemas.openxmlformats.org/drawingml/2006/main">
             <a:fillRect l="0" t="0" r="0" b="0"/>
@@ -1898,6 +1907,7 @@
           <a:lstStyle xmlns:a="http://schemas.openxmlformats.org/drawingml/2006/main"/>
           <a:p xmlns:a="http://schemas.openxmlformats.org/drawingml/2006/main">
             <a:pPr algn="l">
+              <a:buNone/>
               <a:defRPr sz="1950" b="1">
                 <a:solidFill>
                   <a:srgbClr val="E98232"/>
@@ -1984,6 +1994,7 @@
           <a:lstStyle xmlns:a="http://schemas.openxmlformats.org/drawingml/2006/main"/>
           <a:p xmlns:a="http://schemas.openxmlformats.org/drawingml/2006/main">
             <a:pPr algn="l">
+              <a:buNone/>
               <a:defRPr sz="3600" b="1">
                 <a:solidFill>
                   <a:srgbClr val="FFFFFF"/>
@@ -2007,6 +2018,7 @@
           </a:p>
           <a:p xmlns:a="http://schemas.openxmlformats.org/drawingml/2006/main">
             <a:pPr algn="l">
+              <a:buNone/>
               <a:defRPr sz="3600" b="1">
                 <a:solidFill>
                   <a:srgbClr val="FFFFFF"/>
@@ -2064,6 +2076,7 @@
           <a:lstStyle xmlns:a="http://schemas.openxmlformats.org/drawingml/2006/main"/>
           <a:p xmlns:a="http://schemas.openxmlformats.org/drawingml/2006/main">
             <a:pPr algn="l">
+              <a:buNone/>
               <a:defRPr sz="2025" b="1">
                 <a:solidFill>
                   <a:srgbClr val="FFFFFF"/>
@@ -2121,6 +2134,7 @@
           <a:lstStyle xmlns:a="http://schemas.openxmlformats.org/drawingml/2006/main"/>
           <a:p xmlns:a="http://schemas.openxmlformats.org/drawingml/2006/main">
             <a:pPr algn="l">
+              <a:buNone/>
               <a:defRPr sz="2025" b="1">
                 <a:solidFill>
                   <a:srgbClr val="FFFFFF"/>
@@ -2178,6 +2192,7 @@
           <a:lstStyle xmlns:a="http://schemas.openxmlformats.org/drawingml/2006/main"/>
           <a:p xmlns:a="http://schemas.openxmlformats.org/drawingml/2006/main">
             <a:pPr algn="l">
+              <a:buNone/>
               <a:defRPr sz="2025" b="1">
                 <a:solidFill>
                   <a:srgbClr val="FFFFFF"/>
@@ -2235,6 +2250,7 @@
           <a:lstStyle xmlns:a="http://schemas.openxmlformats.org/drawingml/2006/main"/>
           <a:p xmlns:a="http://schemas.openxmlformats.org/drawingml/2006/main">
             <a:pPr algn="l">
+              <a:buNone/>
               <a:defRPr sz="1650" b="0">
                 <a:solidFill>
                   <a:srgbClr val="E98232"/>
@@ -2253,21 +2269,21 @@
                 <a:ea typeface="Arial"/>
                 <a:cs typeface="Arial"/>
               </a:rPr>
-              <a:t>Live URL: add after deployment</a:t>
+              <a:t>Live URL: https://cadenceproject.vercel.app</a:t>
             </a:r>
           </a:p>
         </p:txBody>
       </p:sp>
       <p:pic>
         <p:nvPicPr>
-          <p:cNvPr id="13" name=""/>
+          <p:cNvPr id="15" name=""/>
           <p:cNvPicPr>
             <a:picLocks xmlns:a="http://schemas.openxmlformats.org/drawingml/2006/main" noChangeAspect="1"/>
           </p:cNvPicPr>
           <p:nvPr/>
         </p:nvPicPr>
         <p:blipFill>
-          <a:blip xmlns:r="http://schemas.openxmlformats.org/officeDocument/2006/relationships" xmlns:a="http://schemas.openxmlformats.org/drawingml/2006/main" r:embed="R8425e27033cb48f0"/>
+          <a:blip xmlns:r="http://schemas.openxmlformats.org/officeDocument/2006/relationships" xmlns:a="http://schemas.openxmlformats.org/drawingml/2006/main" r:embed="Rb4fcc10103b8492e"/>
           <a:srcRect xmlns:a="http://schemas.openxmlformats.org/drawingml/2006/main" l="8333" t="0" r="8333" b="0"/>
           <a:stretch xmlns:a="http://schemas.openxmlformats.org/drawingml/2006/main">
             <a:fillRect l="0" t="0" r="0" b="0"/>
@@ -2317,6 +2333,7 @@
           <a:lstStyle xmlns:a="http://schemas.openxmlformats.org/drawingml/2006/main"/>
           <a:p xmlns:a="http://schemas.openxmlformats.org/drawingml/2006/main">
             <a:pPr algn="l">
+              <a:buNone/>
               <a:defRPr sz="1650" b="0">
                 <a:solidFill>
                   <a:srgbClr val="CDD1D5"/>
@@ -2403,6 +2420,7 @@
           <a:lstStyle xmlns:a="http://schemas.openxmlformats.org/drawingml/2006/main"/>
           <a:p xmlns:a="http://schemas.openxmlformats.org/drawingml/2006/main">
             <a:pPr algn="l">
+              <a:buNone/>
               <a:defRPr sz="3600" b="1">
                 <a:solidFill>
                   <a:srgbClr val="111317"/>
@@ -2460,6 +2478,7 @@
           <a:lstStyle xmlns:a="http://schemas.openxmlformats.org/drawingml/2006/main"/>
           <a:p xmlns:a="http://schemas.openxmlformats.org/drawingml/2006/main">
             <a:pPr algn="l">
+              <a:buNone/>
               <a:defRPr sz="1875" b="1">
                 <a:solidFill>
                   <a:srgbClr val="E98232"/>
@@ -2517,6 +2536,7 @@
           <a:lstStyle xmlns:a="http://schemas.openxmlformats.org/drawingml/2006/main"/>
           <a:p xmlns:a="http://schemas.openxmlformats.org/drawingml/2006/main">
             <a:pPr algn="l">
+              <a:buNone/>
               <a:defRPr sz="1725" b="0">
                 <a:solidFill>
                   <a:srgbClr val="29313A"/>
@@ -2574,6 +2594,7 @@
           <a:lstStyle xmlns:a="http://schemas.openxmlformats.org/drawingml/2006/main"/>
           <a:p xmlns:a="http://schemas.openxmlformats.org/drawingml/2006/main">
             <a:pPr algn="ctr">
+              <a:buNone/>
               <a:defRPr sz="2850" b="1">
                 <a:solidFill>
                   <a:srgbClr val="6A737C"/>
@@ -2631,6 +2652,7 @@
           <a:lstStyle xmlns:a="http://schemas.openxmlformats.org/drawingml/2006/main"/>
           <a:p xmlns:a="http://schemas.openxmlformats.org/drawingml/2006/main">
             <a:pPr algn="l">
+              <a:buNone/>
               <a:defRPr sz="1875" b="1">
                 <a:solidFill>
                   <a:srgbClr val="E98232"/>
@@ -2688,6 +2710,7 @@
           <a:lstStyle xmlns:a="http://schemas.openxmlformats.org/drawingml/2006/main"/>
           <a:p xmlns:a="http://schemas.openxmlformats.org/drawingml/2006/main">
             <a:pPr algn="l">
+              <a:buNone/>
               <a:defRPr sz="1725" b="0">
                 <a:solidFill>
                   <a:srgbClr val="29313A"/>
@@ -2745,6 +2768,7 @@
           <a:lstStyle xmlns:a="http://schemas.openxmlformats.org/drawingml/2006/main"/>
           <a:p xmlns:a="http://schemas.openxmlformats.org/drawingml/2006/main">
             <a:pPr algn="ctr">
+              <a:buNone/>
               <a:defRPr sz="2850" b="1">
                 <a:solidFill>
                   <a:srgbClr val="6A737C"/>
@@ -2802,6 +2826,7 @@
           <a:lstStyle xmlns:a="http://schemas.openxmlformats.org/drawingml/2006/main"/>
           <a:p xmlns:a="http://schemas.openxmlformats.org/drawingml/2006/main">
             <a:pPr algn="l">
+              <a:buNone/>
               <a:defRPr sz="1875" b="1">
                 <a:solidFill>
                   <a:srgbClr val="E98232"/>
@@ -2859,6 +2884,7 @@
           <a:lstStyle xmlns:a="http://schemas.openxmlformats.org/drawingml/2006/main"/>
           <a:p xmlns:a="http://schemas.openxmlformats.org/drawingml/2006/main">
             <a:pPr algn="l">
+              <a:buNone/>
               <a:defRPr sz="1725" b="0">
                 <a:solidFill>
                   <a:srgbClr val="29313A"/>
@@ -2916,6 +2942,7 @@
           <a:lstStyle xmlns:a="http://schemas.openxmlformats.org/drawingml/2006/main"/>
           <a:p xmlns:a="http://schemas.openxmlformats.org/drawingml/2006/main">
             <a:pPr algn="l">
+              <a:buNone/>
               <a:defRPr sz="1650" b="0">
                 <a:solidFill>
                   <a:srgbClr val="6A737C"/>
@@ -2973,6 +3000,7 @@
           <a:lstStyle xmlns:a="http://schemas.openxmlformats.org/drawingml/2006/main"/>
           <a:p xmlns:a="http://schemas.openxmlformats.org/drawingml/2006/main">
             <a:pPr algn="l">
+              <a:buNone/>
               <a:defRPr sz="1650" b="0">
                 <a:solidFill>
                   <a:srgbClr val="6A737C"/>
@@ -3030,6 +3058,7 @@
           <a:lstStyle xmlns:a="http://schemas.openxmlformats.org/drawingml/2006/main"/>
           <a:p xmlns:a="http://schemas.openxmlformats.org/drawingml/2006/main">
             <a:pPr algn="l">
+              <a:buNone/>
               <a:defRPr sz="1650" b="1">
                 <a:solidFill>
                   <a:srgbClr val="111317"/>
@@ -3116,6 +3145,7 @@
           <a:lstStyle xmlns:a="http://schemas.openxmlformats.org/drawingml/2006/main"/>
           <a:p xmlns:a="http://schemas.openxmlformats.org/drawingml/2006/main">
             <a:pPr algn="l">
+              <a:buNone/>
               <a:defRPr sz="3675" b="1">
                 <a:solidFill>
                   <a:srgbClr val="FFFFFF"/>
@@ -3134,11 +3164,12 @@
                 <a:ea typeface="Arial"/>
                 <a:cs typeface="Arial"/>
               </a:rPr>
-              <a:t>What ships before</a:t>
+              <a:t>Lessons learned</a:t>
             </a:r>
           </a:p>
           <a:p xmlns:a="http://schemas.openxmlformats.org/drawingml/2006/main">
             <a:pPr algn="l">
+              <a:buNone/>
               <a:defRPr sz="3675" b="1">
                 <a:solidFill>
                   <a:srgbClr val="FFFFFF"/>
@@ -3157,7 +3188,7 @@
                 <a:ea typeface="Arial"/>
                 <a:cs typeface="Arial"/>
               </a:rPr>
-              <a:t>the live pitch</a:t>
+              <a:t>and next steps</a:t>
             </a:r>
           </a:p>
         </p:txBody>
@@ -3196,6 +3227,7 @@
           <a:lstStyle xmlns:a="http://schemas.openxmlformats.org/drawingml/2006/main"/>
           <a:p xmlns:a="http://schemas.openxmlformats.org/drawingml/2006/main">
             <a:pPr algn="l">
+              <a:buNone/>
               <a:defRPr sz="1875" b="0">
                 <a:solidFill>
                   <a:srgbClr val="F4F4F2"/>
@@ -3214,7 +3246,7 @@
                 <a:ea typeface="Arial"/>
                 <a:cs typeface="Arial"/>
               </a:rPr>
-              <a:t>01  Run the Supabase schema and add server secrets</a:t>
+              <a:t>01  Lesson: keep API keys on the server.</a:t>
             </a:r>
           </a:p>
         </p:txBody>
@@ -3253,6 +3285,7 @@
           <a:lstStyle xmlns:a="http://schemas.openxmlformats.org/drawingml/2006/main"/>
           <a:p xmlns:a="http://schemas.openxmlformats.org/drawingml/2006/main">
             <a:pPr algn="l">
+              <a:buNone/>
               <a:defRPr sz="1875" b="0">
                 <a:solidFill>
                   <a:srgbClr val="F4F4F2"/>
@@ -3271,7 +3304,7 @@
                 <a:ea typeface="Arial"/>
                 <a:cs typeface="Arial"/>
               </a:rPr>
-              <a:t>02  Deploy on Vercel and add the public URL</a:t>
+              <a:t>02  Challenge: Gemini availability can interrupt analysis.</a:t>
             </a:r>
           </a:p>
         </p:txBody>
@@ -3310,6 +3343,7 @@
           <a:lstStyle xmlns:a="http://schemas.openxmlformats.org/drawingml/2006/main"/>
           <a:p xmlns:a="http://schemas.openxmlformats.org/drawingml/2006/main">
             <a:pPr algn="l">
+              <a:buNone/>
               <a:defRPr sz="1875" b="0">
                 <a:solidFill>
                   <a:srgbClr val="F4F4F2"/>
@@ -3328,7 +3362,7 @@
                 <a:ea typeface="Arial"/>
                 <a:cs typeface="Arial"/>
               </a:rPr>
-              <a:t>03  Test microphone, analysis, and saved history on a phone</a:t>
+              <a:t>03  Next: test on phones and add account sign-in.</a:t>
             </a:r>
           </a:p>
         </p:txBody>
@@ -3362,11 +3396,12 @@
         </p:spPr>
         <p:txBody>
           <a:bodyPr xmlns:a="http://schemas.openxmlformats.org/drawingml/2006/main" anchor="ctr">
-            <a:normAutofit fontScale="99552"/>
+            <a:normAutofit fontScale="100000"/>
           </a:bodyPr>
           <a:lstStyle xmlns:a="http://schemas.openxmlformats.org/drawingml/2006/main"/>
           <a:p xmlns:a="http://schemas.openxmlformats.org/drawingml/2006/main">
             <a:pPr algn="l">
+              <a:buNone/>
               <a:defRPr sz="1650" b="0">
                 <a:solidFill>
                   <a:srgbClr val="C9CDD1"/>
@@ -3385,7 +3420,7 @@
                 <a:ea typeface="Arial"/>
                 <a:cs typeface="Arial"/>
               </a:rPr>
-              <a:t>Typecheck and production build pass. Live credentials and phone test are still pending.</a:t>
+              <a:t>Build and TypeScript checks pass; one live recording and phone test remain.</a:t>
             </a:r>
           </a:p>
         </p:txBody>
@@ -3424,6 +3459,7 @@
           <a:lstStyle xmlns:a="http://schemas.openxmlformats.org/drawingml/2006/main"/>
           <a:p xmlns:a="http://schemas.openxmlformats.org/drawingml/2006/main">
             <a:pPr algn="l">
+              <a:buNone/>
               <a:defRPr sz="1800" b="1">
                 <a:solidFill>
                   <a:srgbClr val="E98232"/>
@@ -3442,7 +3478,7 @@
                 <a:ea typeface="Arial"/>
                 <a:cs typeface="Arial"/>
               </a:rPr>
-              <a:t>Next: add the deployed URL, then show two flows live.</a:t>
+              <a:t>Live demo: https://cadenceproject.vercel.app</a:t>
             </a:r>
           </a:p>
         </p:txBody>

</xml_diff>